<commit_message>
Update manuscript title and visual abstract
Revised the manuscript title in the cover letter to 'Traumatic Page Kidney: A Systematic Review and Case Report of Bilateral Gerota's Fascia Release' and updated the associated visual abstract presentation.
</commit_message>
<xml_diff>
--- a/manuscript_files/TPK_VisualAbstract.pptx
+++ b/manuscript_files/TPK_VisualAbstract.pptx
@@ -197,7 +197,7 @@
           <a:p>
             <a:fld id="{98E81BC4-1899-4A12-82FE-E205F6E57443}" type="datetimeFigureOut">
               <a:rPr lang="en-AU" smtClean="0"/>
-              <a:t>17/7/2025</a:t>
+              <a:t>18/7/2025</a:t>
             </a:fld>
             <a:endParaRPr lang="en-AU"/>
           </a:p>
@@ -680,7 +680,7 @@
           <a:p>
             <a:fld id="{24C38CEC-66B5-8A49-AC42-B38002A774F0}" type="datetimeFigureOut">
               <a:rPr lang="en-US" smtClean="0"/>
-              <a:t>7/17/25</a:t>
+              <a:t>7/18/25</a:t>
             </a:fld>
             <a:endParaRPr lang="en-US"/>
           </a:p>
@@ -850,7 +850,7 @@
           <a:p>
             <a:fld id="{24C38CEC-66B5-8A49-AC42-B38002A774F0}" type="datetimeFigureOut">
               <a:rPr lang="en-US" smtClean="0"/>
-              <a:t>7/17/25</a:t>
+              <a:t>7/18/25</a:t>
             </a:fld>
             <a:endParaRPr lang="en-US"/>
           </a:p>
@@ -1030,7 +1030,7 @@
           <a:p>
             <a:fld id="{24C38CEC-66B5-8A49-AC42-B38002A774F0}" type="datetimeFigureOut">
               <a:rPr lang="en-US" smtClean="0"/>
-              <a:t>7/17/25</a:t>
+              <a:t>7/18/25</a:t>
             </a:fld>
             <a:endParaRPr lang="en-US"/>
           </a:p>
@@ -1200,7 +1200,7 @@
           <a:p>
             <a:fld id="{24C38CEC-66B5-8A49-AC42-B38002A774F0}" type="datetimeFigureOut">
               <a:rPr lang="en-US" smtClean="0"/>
-              <a:t>7/17/25</a:t>
+              <a:t>7/18/25</a:t>
             </a:fld>
             <a:endParaRPr lang="en-US"/>
           </a:p>
@@ -1446,7 +1446,7 @@
           <a:p>
             <a:fld id="{24C38CEC-66B5-8A49-AC42-B38002A774F0}" type="datetimeFigureOut">
               <a:rPr lang="en-US" smtClean="0"/>
-              <a:t>7/17/25</a:t>
+              <a:t>7/18/25</a:t>
             </a:fld>
             <a:endParaRPr lang="en-US"/>
           </a:p>
@@ -1678,7 +1678,7 @@
           <a:p>
             <a:fld id="{24C38CEC-66B5-8A49-AC42-B38002A774F0}" type="datetimeFigureOut">
               <a:rPr lang="en-US" smtClean="0"/>
-              <a:t>7/17/25</a:t>
+              <a:t>7/18/25</a:t>
             </a:fld>
             <a:endParaRPr lang="en-US"/>
           </a:p>
@@ -2045,7 +2045,7 @@
           <a:p>
             <a:fld id="{24C38CEC-66B5-8A49-AC42-B38002A774F0}" type="datetimeFigureOut">
               <a:rPr lang="en-US" smtClean="0"/>
-              <a:t>7/17/25</a:t>
+              <a:t>7/18/25</a:t>
             </a:fld>
             <a:endParaRPr lang="en-US"/>
           </a:p>
@@ -2163,7 +2163,7 @@
           <a:p>
             <a:fld id="{24C38CEC-66B5-8A49-AC42-B38002A774F0}" type="datetimeFigureOut">
               <a:rPr lang="en-US" smtClean="0"/>
-              <a:t>7/17/25</a:t>
+              <a:t>7/18/25</a:t>
             </a:fld>
             <a:endParaRPr lang="en-US"/>
           </a:p>
@@ -2258,7 +2258,7 @@
           <a:p>
             <a:fld id="{24C38CEC-66B5-8A49-AC42-B38002A774F0}" type="datetimeFigureOut">
               <a:rPr lang="en-US" smtClean="0"/>
-              <a:t>7/17/25</a:t>
+              <a:t>7/18/25</a:t>
             </a:fld>
             <a:endParaRPr lang="en-US"/>
           </a:p>
@@ -2535,7 +2535,7 @@
           <a:p>
             <a:fld id="{24C38CEC-66B5-8A49-AC42-B38002A774F0}" type="datetimeFigureOut">
               <a:rPr lang="en-US" smtClean="0"/>
-              <a:t>7/17/25</a:t>
+              <a:t>7/18/25</a:t>
             </a:fld>
             <a:endParaRPr lang="en-US"/>
           </a:p>
@@ -2792,7 +2792,7 @@
           <a:p>
             <a:fld id="{24C38CEC-66B5-8A49-AC42-B38002A774F0}" type="datetimeFigureOut">
               <a:rPr lang="en-US" smtClean="0"/>
-              <a:t>7/17/25</a:t>
+              <a:t>7/18/25</a:t>
             </a:fld>
             <a:endParaRPr lang="en-US"/>
           </a:p>
@@ -3005,7 +3005,7 @@
           <a:p>
             <a:fld id="{24C38CEC-66B5-8A49-AC42-B38002A774F0}" type="datetimeFigureOut">
               <a:rPr lang="en-US" smtClean="0"/>
-              <a:t>7/17/25</a:t>
+              <a:t>7/18/25</a:t>
             </a:fld>
             <a:endParaRPr lang="en-US"/>
           </a:p>
@@ -3482,14 +3482,13 @@
         </p:spPr>
         <p:txBody>
           <a:bodyPr>
-            <a:normAutofit fontScale="90000"/>
+            <a:noAutofit/>
           </a:bodyPr>
           <a:lstStyle/>
           <a:p>
-            <a:pPr algn="ctr"/>
-            <a:r>
-              <a:rPr lang="en-US" sz="3200" b="1" dirty="0"/>
-              <a:t>Bilateral Traumatic Page Kidney: First Surgical Case and Systematic Review</a:t>
+            <a:r>
+              <a:rPr lang="en-US" sz="2400" dirty="0"/>
+              <a:t>Traumatic Page Kidney: A Systematic Review and Case Report of Bilateral Gerota's Fascia Release</a:t>
             </a:r>
           </a:p>
         </p:txBody>

</xml_diff>